<commit_message>
Add provider-neutral catalog evidence layer
</commit_message>
<xml_diff>
--- a/artifacts/AI_BUILD_CREW_OVERVIEW.pptx
+++ b/artifacts/AI_BUILD_CREW_OVERVIEW.pptx
@@ -2,18 +2,18 @@
 <file path=ppt/presentation.xml><?xml version="1.0" encoding="utf-8"?>
 <p:presentation xmlns:p="http://schemas.openxmlformats.org/presentationml/2006/main">
   <p:sldMasterIdLst>
-    <p:sldMasterId xmlns:r="http://schemas.openxmlformats.org/officeDocument/2006/relationships" id="2147483648" r:id="R153d310616c243d1"/>
+    <p:sldMasterId xmlns:r="http://schemas.openxmlformats.org/officeDocument/2006/relationships" id="2147483648" r:id="Ra9185a3107cf40bc"/>
   </p:sldMasterIdLst>
   <p:notesMasterIdLst>
-    <p:notesMasterId xmlns:r="http://schemas.openxmlformats.org/officeDocument/2006/relationships" r:id="Rb0256a4e684f486d"/>
+    <p:notesMasterId xmlns:r="http://schemas.openxmlformats.org/officeDocument/2006/relationships" r:id="Re63049ed179d4ab1"/>
   </p:notesMasterIdLst>
   <p:sldIdLst>
-    <p:sldId xmlns:r="http://schemas.openxmlformats.org/officeDocument/2006/relationships" id="256" r:id="Rc6b5dbce9c80448d"/>
-    <p:sldId xmlns:r="http://schemas.openxmlformats.org/officeDocument/2006/relationships" id="257" r:id="Red550c49abe34818"/>
-    <p:sldId xmlns:r="http://schemas.openxmlformats.org/officeDocument/2006/relationships" id="258" r:id="R042e8a60040c40f7"/>
-    <p:sldId xmlns:r="http://schemas.openxmlformats.org/officeDocument/2006/relationships" id="259" r:id="Rc414d665018641d3"/>
-    <p:sldId xmlns:r="http://schemas.openxmlformats.org/officeDocument/2006/relationships" id="260" r:id="R9c3d7e5ef3e84c4b"/>
-    <p:sldId xmlns:r="http://schemas.openxmlformats.org/officeDocument/2006/relationships" id="261" r:id="Rcad20eef428f4cb7"/>
+    <p:sldId xmlns:r="http://schemas.openxmlformats.org/officeDocument/2006/relationships" id="256" r:id="R9787133773714506"/>
+    <p:sldId xmlns:r="http://schemas.openxmlformats.org/officeDocument/2006/relationships" id="257" r:id="Ra9c60f29475b475c"/>
+    <p:sldId xmlns:r="http://schemas.openxmlformats.org/officeDocument/2006/relationships" id="258" r:id="Rad94850b0aac4af2"/>
+    <p:sldId xmlns:r="http://schemas.openxmlformats.org/officeDocument/2006/relationships" id="259" r:id="Rd2cae6621ff944b3"/>
+    <p:sldId xmlns:r="http://schemas.openxmlformats.org/officeDocument/2006/relationships" id="260" r:id="R4bae8fd54c124126"/>
+    <p:sldId xmlns:r="http://schemas.openxmlformats.org/officeDocument/2006/relationships" id="261" r:id="Rc27c1ba6729b4aa6"/>
   </p:sldIdLst>
   <p:sldSz cx="12192000" cy="6858000"/>
   <p:notesSz cx="6858000" cy="9144000"/>
@@ -1015,7 +1015,7 @@
   </p:cSld>
   <p:clrMap bg1="lt1" tx1="dk1" bg2="lt2" tx2="dk2" accent1="accent1" accent2="accent2" accent3="accent3" accent4="accent4" accent5="accent5" accent6="accent6" hlink="hlink" folHlink="folHlink"/>
   <p:sldLayoutIdLst>
-    <p:sldLayoutId xmlns:r="http://schemas.openxmlformats.org/officeDocument/2006/relationships" id="2147483649" r:id="R186d168bdab74e14"/>
+    <p:sldLayoutId xmlns:r="http://schemas.openxmlformats.org/officeDocument/2006/relationships" id="2147483649" r:id="R558709fcb54b4f33"/>
   </p:sldLayoutIdLst>
   <p:txStyles>
     <p:titleStyle>
@@ -1559,7 +1559,7 @@
           <p:cNvPr id="4" name="Title-3-1">
             <a:extLst xmlns:a="http://schemas.openxmlformats.org/drawingml/2006/main">
               <a:ext uri="{FF2B5EF4-FFF2-40B4-BE49-F238E27FC236}">
-                <a16:creationId xmlns:a16="http://schemas.microsoft.com/office/drawing/2014/main" id="{474B12FD-64AA-47BD-8725-BC86901F7DCC}"/>
+                <a16:creationId xmlns:a16="http://schemas.microsoft.com/office/drawing/2014/main" id="{8398CEE5-3C9F-4D1D-9462-BC7DA2F78787}"/>
               </a:ext>
             </a:extLst>
           </p:cNvPr>
@@ -1604,7 +1604,7 @@
           <p:cNvPr id="2" name="Subtitle-4-2">
             <a:extLst xmlns:a="http://schemas.openxmlformats.org/drawingml/2006/main">
               <a:ext uri="{FF2B5EF4-FFF2-40B4-BE49-F238E27FC236}">
-                <a16:creationId xmlns:a16="http://schemas.microsoft.com/office/drawing/2014/main" id="{EE14E30B-4EAD-472F-9A94-D15F6DF0A669}"/>
+                <a16:creationId xmlns:a16="http://schemas.microsoft.com/office/drawing/2014/main" id="{5B3338A1-2A49-4B7D-ADD0-AC27FD62F0DF}"/>
               </a:ext>
             </a:extLst>
           </p:cNvPr>
@@ -1649,7 +1649,7 @@
           <p:cNvPr id="3" name="Subtitle-4-3">
             <a:extLst xmlns:a="http://schemas.openxmlformats.org/drawingml/2006/main">
               <a:ext uri="{FF2B5EF4-FFF2-40B4-BE49-F238E27FC236}">
-                <a16:creationId xmlns:a16="http://schemas.microsoft.com/office/drawing/2014/main" id="{20B5305F-49C1-4983-92BD-979777C413CC}"/>
+                <a16:creationId xmlns:a16="http://schemas.microsoft.com/office/drawing/2014/main" id="{76549BB3-FB64-4A37-92B1-48173576257C}"/>
               </a:ext>
             </a:extLst>
           </p:cNvPr>
@@ -1692,7 +1692,7 @@
     </p:spTree>
     <p:extLst>
       <p:ext uri="{BB962C8B-B14F-4D97-AF65-F5344CB8AC3E}">
-        <p14:creationId xmlns:p14="http://schemas.microsoft.com/office/powerpoint/2010/main" val="2127258839"/>
+        <p14:creationId xmlns:p14="http://schemas.microsoft.com/office/powerpoint/2010/main" val="1297637629"/>
       </p:ext>
     </p:extLst>
   </p:cSld>
@@ -1716,7 +1716,7 @@
           <p:cNvPr id="5" name="Google-Shape-532-p58-2">
             <a:extLst xmlns:a="http://schemas.openxmlformats.org/drawingml/2006/main">
               <a:ext uri="{FF2B5EF4-FFF2-40B4-BE49-F238E27FC236}">
-                <a16:creationId xmlns:a16="http://schemas.microsoft.com/office/drawing/2014/main" id="{334E291F-2704-41F3-A557-8D5357D03D14}"/>
+                <a16:creationId xmlns:a16="http://schemas.microsoft.com/office/drawing/2014/main" id="{8042767A-A159-4A55-91AB-56897DAC4EA6}"/>
               </a:ext>
             </a:extLst>
           </p:cNvPr>
@@ -1761,7 +1761,7 @@
           <p:cNvPr id="2" name="Google-Shape-533-p58-3">
             <a:extLst xmlns:a="http://schemas.openxmlformats.org/drawingml/2006/main">
               <a:ext uri="{FF2B5EF4-FFF2-40B4-BE49-F238E27FC236}">
-                <a16:creationId xmlns:a16="http://schemas.microsoft.com/office/drawing/2014/main" id="{42F61219-339A-4F91-A478-8F714FC06243}"/>
+                <a16:creationId xmlns:a16="http://schemas.microsoft.com/office/drawing/2014/main" id="{12E27B63-8284-4CF8-9D0D-8CA7E6DBA913}"/>
               </a:ext>
             </a:extLst>
           </p:cNvPr>
@@ -1806,7 +1806,7 @@
           <p:cNvPr id="3" name="Google-Shape-534-p58-4">
             <a:extLst xmlns:a="http://schemas.openxmlformats.org/drawingml/2006/main">
               <a:ext uri="{FF2B5EF4-FFF2-40B4-BE49-F238E27FC236}">
-                <a16:creationId xmlns:a16="http://schemas.microsoft.com/office/drawing/2014/main" id="{17018B86-A222-470A-9906-5F19762F5F90}"/>
+                <a16:creationId xmlns:a16="http://schemas.microsoft.com/office/drawing/2014/main" id="{56496EEE-D7F7-4FC8-B612-C20BAA6C50CB}"/>
               </a:ext>
             </a:extLst>
           </p:cNvPr>
@@ -1866,7 +1866,7 @@
           <p:cNvPr id="4" name="Content-Placeholder-3-5">
             <a:extLst xmlns:a="http://schemas.openxmlformats.org/drawingml/2006/main">
               <a:ext uri="{FF2B5EF4-FFF2-40B4-BE49-F238E27FC236}">
-                <a16:creationId xmlns:a16="http://schemas.microsoft.com/office/drawing/2014/main" id="{C55150B5-FC03-4B53-ABF9-01C8DEE5DF49}"/>
+                <a16:creationId xmlns:a16="http://schemas.microsoft.com/office/drawing/2014/main" id="{75B81F96-C22E-4C50-A4F0-47752A40351A}"/>
               </a:ext>
             </a:extLst>
           </p:cNvPr>
@@ -1924,7 +1924,7 @@
     </p:spTree>
     <p:extLst>
       <p:ext uri="{BB962C8B-B14F-4D97-AF65-F5344CB8AC3E}">
-        <p14:creationId xmlns:p14="http://schemas.microsoft.com/office/powerpoint/2010/main" val="176325165"/>
+        <p14:creationId xmlns:p14="http://schemas.microsoft.com/office/powerpoint/2010/main" val="1037340262"/>
       </p:ext>
     </p:extLst>
   </p:cSld>
@@ -1948,7 +1948,7 @@
           <p:cNvPr id="7" name="Slide-Number-Placeholder-1-2">
             <a:extLst xmlns:a="http://schemas.openxmlformats.org/drawingml/2006/main">
               <a:ext uri="{FF2B5EF4-FFF2-40B4-BE49-F238E27FC236}">
-                <a16:creationId xmlns:a16="http://schemas.microsoft.com/office/drawing/2014/main" id="{4CCA946E-B8F4-4D69-B539-E2E5D560C031}"/>
+                <a16:creationId xmlns:a16="http://schemas.microsoft.com/office/drawing/2014/main" id="{C1F57483-1D21-4DA1-A2D6-134D48882F4E}"/>
               </a:ext>
             </a:extLst>
           </p:cNvPr>
@@ -1991,7 +1991,7 @@
           <p:cNvPr id="2" name="Title-2-3">
             <a:extLst xmlns:a="http://schemas.openxmlformats.org/drawingml/2006/main">
               <a:ext uri="{FF2B5EF4-FFF2-40B4-BE49-F238E27FC236}">
-                <a16:creationId xmlns:a16="http://schemas.microsoft.com/office/drawing/2014/main" id="{42A44FD8-FD7B-4E13-9429-861D36CD8F79}"/>
+                <a16:creationId xmlns:a16="http://schemas.microsoft.com/office/drawing/2014/main" id="{9F3D89FC-7B7A-4FAF-AA3D-A88049AFC511}"/>
               </a:ext>
             </a:extLst>
           </p:cNvPr>
@@ -2036,7 +2036,7 @@
           <p:cNvPr id="3" name="Content-Placeholder-9-4">
             <a:extLst xmlns:a="http://schemas.openxmlformats.org/drawingml/2006/main">
               <a:ext uri="{FF2B5EF4-FFF2-40B4-BE49-F238E27FC236}">
-                <a16:creationId xmlns:a16="http://schemas.microsoft.com/office/drawing/2014/main" id="{29FDB528-C676-4AE9-BCA5-7E83B53F00E8}"/>
+                <a16:creationId xmlns:a16="http://schemas.microsoft.com/office/drawing/2014/main" id="{847B81FD-E9E4-41E7-9F2A-75D5EB306353}"/>
               </a:ext>
             </a:extLst>
           </p:cNvPr>
@@ -2095,7 +2095,7 @@
           <p:cNvPr id="4" name="Content-Placeholder-10-5">
             <a:extLst xmlns:a="http://schemas.openxmlformats.org/drawingml/2006/main">
               <a:ext uri="{FF2B5EF4-FFF2-40B4-BE49-F238E27FC236}">
-                <a16:creationId xmlns:a16="http://schemas.microsoft.com/office/drawing/2014/main" id="{9ABDC99A-B1AF-4217-A165-E6920152393F}"/>
+                <a16:creationId xmlns:a16="http://schemas.microsoft.com/office/drawing/2014/main" id="{81E1CA3C-7D0C-4F6B-BDBF-4019A50FF4DC}"/>
               </a:ext>
             </a:extLst>
           </p:cNvPr>
@@ -2153,7 +2153,7 @@
           <p:cNvPr id="5" name="Content-Placeholder-9-6">
             <a:extLst xmlns:a="http://schemas.openxmlformats.org/drawingml/2006/main">
               <a:ext uri="{FF2B5EF4-FFF2-40B4-BE49-F238E27FC236}">
-                <a16:creationId xmlns:a16="http://schemas.microsoft.com/office/drawing/2014/main" id="{47A11690-4B1B-43A4-8649-1895AC9232ED}"/>
+                <a16:creationId xmlns:a16="http://schemas.microsoft.com/office/drawing/2014/main" id="{A7AF3909-426A-47D3-880A-8E3CAD3EDEAC}"/>
               </a:ext>
             </a:extLst>
           </p:cNvPr>
@@ -2213,7 +2213,7 @@
           <p:cNvPr id="6" name="Content-Placeholder-10-7">
             <a:extLst xmlns:a="http://schemas.openxmlformats.org/drawingml/2006/main">
               <a:ext uri="{FF2B5EF4-FFF2-40B4-BE49-F238E27FC236}">
-                <a16:creationId xmlns:a16="http://schemas.microsoft.com/office/drawing/2014/main" id="{76B5BC75-746A-40F0-87D9-6638849E8284}"/>
+                <a16:creationId xmlns:a16="http://schemas.microsoft.com/office/drawing/2014/main" id="{217D19C8-7755-40B5-B3DC-82C5D323E065}"/>
               </a:ext>
             </a:extLst>
           </p:cNvPr>
@@ -2271,7 +2271,7 @@
     </p:spTree>
     <p:extLst>
       <p:ext uri="{BB962C8B-B14F-4D97-AF65-F5344CB8AC3E}">
-        <p14:creationId xmlns:p14="http://schemas.microsoft.com/office/powerpoint/2010/main" val="1798122045"/>
+        <p14:creationId xmlns:p14="http://schemas.microsoft.com/office/powerpoint/2010/main" val="436206546"/>
       </p:ext>
     </p:extLst>
   </p:cSld>
@@ -2295,7 +2295,7 @@
           <p:cNvPr id="13" name="Slide-Number-Placeholder-3-2">
             <a:extLst xmlns:a="http://schemas.openxmlformats.org/drawingml/2006/main">
               <a:ext uri="{FF2B5EF4-FFF2-40B4-BE49-F238E27FC236}">
-                <a16:creationId xmlns:a16="http://schemas.microsoft.com/office/drawing/2014/main" id="{6F832430-5257-458F-BB30-469710EB2CDF}"/>
+                <a16:creationId xmlns:a16="http://schemas.microsoft.com/office/drawing/2014/main" id="{4B4399CD-1256-4B66-916B-84D4DF137B3C}"/>
               </a:ext>
             </a:extLst>
           </p:cNvPr>
@@ -2338,7 +2338,7 @@
           <p:cNvPr id="2" name="Title-10-3">
             <a:extLst xmlns:a="http://schemas.openxmlformats.org/drawingml/2006/main">
               <a:ext uri="{FF2B5EF4-FFF2-40B4-BE49-F238E27FC236}">
-                <a16:creationId xmlns:a16="http://schemas.microsoft.com/office/drawing/2014/main" id="{F4F56DB2-6B74-42FB-9804-F42CC1ADF6F1}"/>
+                <a16:creationId xmlns:a16="http://schemas.microsoft.com/office/drawing/2014/main" id="{D597EB95-687B-4FC2-A4B6-CE552F6082BB}"/>
               </a:ext>
             </a:extLst>
           </p:cNvPr>
@@ -2405,7 +2405,7 @@
           <p:cNvPr id="4" name="Google-Shape-2260-p159-5">
             <a:extLst xmlns:a="http://schemas.openxmlformats.org/drawingml/2006/main">
               <a:ext uri="{FF2B5EF4-FFF2-40B4-BE49-F238E27FC236}">
-                <a16:creationId xmlns:a16="http://schemas.microsoft.com/office/drawing/2014/main" id="{65CECEB0-3322-4F64-9CB5-C1F0773A6A94}"/>
+                <a16:creationId xmlns:a16="http://schemas.microsoft.com/office/drawing/2014/main" id="{3BA24476-8E3C-4BE2-853E-7FA56DFFED95}"/>
               </a:ext>
             </a:extLst>
           </p:cNvPr>
@@ -2432,7 +2432,7 @@
           <p:cNvPr id="5" name="Google-Shape-2261-p159-6">
             <a:extLst xmlns:a="http://schemas.openxmlformats.org/drawingml/2006/main">
               <a:ext uri="{FF2B5EF4-FFF2-40B4-BE49-F238E27FC236}">
-                <a16:creationId xmlns:a16="http://schemas.microsoft.com/office/drawing/2014/main" id="{C390B0EC-C831-438B-AE5D-265AAC77500F}"/>
+                <a16:creationId xmlns:a16="http://schemas.microsoft.com/office/drawing/2014/main" id="{FC982D8F-88F9-4E4A-BD2F-ED8B7F67C534}"/>
               </a:ext>
             </a:extLst>
           </p:cNvPr>
@@ -2459,7 +2459,7 @@
           <p:cNvPr id="6" name="Google-Shape-2262-p159-7">
             <a:extLst xmlns:a="http://schemas.openxmlformats.org/drawingml/2006/main">
               <a:ext uri="{FF2B5EF4-FFF2-40B4-BE49-F238E27FC236}">
-                <a16:creationId xmlns:a16="http://schemas.microsoft.com/office/drawing/2014/main" id="{E6E96CA2-E870-403F-9FA5-64C6EE5382ED}"/>
+                <a16:creationId xmlns:a16="http://schemas.microsoft.com/office/drawing/2014/main" id="{0AFBC0E8-6819-4E88-B2C1-0F6303045566}"/>
               </a:ext>
             </a:extLst>
           </p:cNvPr>
@@ -2486,7 +2486,7 @@
           <p:cNvPr id="7" name="Content-Placeholder-15-8">
             <a:extLst xmlns:a="http://schemas.openxmlformats.org/drawingml/2006/main">
               <a:ext uri="{FF2B5EF4-FFF2-40B4-BE49-F238E27FC236}">
-                <a16:creationId xmlns:a16="http://schemas.microsoft.com/office/drawing/2014/main" id="{31E72AE3-8451-468A-8FFE-A3570A7B04BA}"/>
+                <a16:creationId xmlns:a16="http://schemas.microsoft.com/office/drawing/2014/main" id="{539B7EB2-C5C6-40B6-B7BA-9E48176D822B}"/>
               </a:ext>
             </a:extLst>
           </p:cNvPr>
@@ -2531,7 +2531,7 @@
           <p:cNvPr id="8" name="Content-Placeholder-15-9">
             <a:extLst xmlns:a="http://schemas.openxmlformats.org/drawingml/2006/main">
               <a:ext uri="{FF2B5EF4-FFF2-40B4-BE49-F238E27FC236}">
-                <a16:creationId xmlns:a16="http://schemas.microsoft.com/office/drawing/2014/main" id="{CA7AEF96-E4E7-497E-8152-86F3CC001AD4}"/>
+                <a16:creationId xmlns:a16="http://schemas.microsoft.com/office/drawing/2014/main" id="{7F5691B0-1BE4-4D5A-BF25-3A12F3E59C37}"/>
               </a:ext>
             </a:extLst>
           </p:cNvPr>
@@ -2576,7 +2576,7 @@
           <p:cNvPr id="9" name="Content-Placeholder-15-10">
             <a:extLst xmlns:a="http://schemas.openxmlformats.org/drawingml/2006/main">
               <a:ext uri="{FF2B5EF4-FFF2-40B4-BE49-F238E27FC236}">
-                <a16:creationId xmlns:a16="http://schemas.microsoft.com/office/drawing/2014/main" id="{96896984-CA7E-4801-845A-65182ADABFE1}"/>
+                <a16:creationId xmlns:a16="http://schemas.microsoft.com/office/drawing/2014/main" id="{C2C19711-CD97-4020-95CF-898C48C02A5F}"/>
               </a:ext>
             </a:extLst>
           </p:cNvPr>
@@ -2621,7 +2621,7 @@
           <p:cNvPr id="10" name="Text-Placeholder-16-11">
             <a:extLst xmlns:a="http://schemas.openxmlformats.org/drawingml/2006/main">
               <a:ext uri="{FF2B5EF4-FFF2-40B4-BE49-F238E27FC236}">
-                <a16:creationId xmlns:a16="http://schemas.microsoft.com/office/drawing/2014/main" id="{E3EDB53C-EDF3-4BAE-9BB9-D0026BAC2607}"/>
+                <a16:creationId xmlns:a16="http://schemas.microsoft.com/office/drawing/2014/main" id="{742FD172-0C30-45B9-87D1-595EBD1DA31F}"/>
               </a:ext>
             </a:extLst>
           </p:cNvPr>
@@ -2681,7 +2681,7 @@
           <p:cNvPr id="11" name="Text-Placeholder-16-12">
             <a:extLst xmlns:a="http://schemas.openxmlformats.org/drawingml/2006/main">
               <a:ext uri="{FF2B5EF4-FFF2-40B4-BE49-F238E27FC236}">
-                <a16:creationId xmlns:a16="http://schemas.microsoft.com/office/drawing/2014/main" id="{6E0008A9-8202-4C1F-9B18-55F39803BC34}"/>
+                <a16:creationId xmlns:a16="http://schemas.microsoft.com/office/drawing/2014/main" id="{D3A86040-5B28-4654-86F0-6621C499CF9A}"/>
               </a:ext>
             </a:extLst>
           </p:cNvPr>
@@ -2741,7 +2741,7 @@
           <p:cNvPr id="12" name="Text-Placeholder-16-13">
             <a:extLst xmlns:a="http://schemas.openxmlformats.org/drawingml/2006/main">
               <a:ext uri="{FF2B5EF4-FFF2-40B4-BE49-F238E27FC236}">
-                <a16:creationId xmlns:a16="http://schemas.microsoft.com/office/drawing/2014/main" id="{ED99A0E5-CF4A-448C-BCA1-7E004A0C048F}"/>
+                <a16:creationId xmlns:a16="http://schemas.microsoft.com/office/drawing/2014/main" id="{C6F48E0B-EF95-497A-9CC5-997385972078}"/>
               </a:ext>
             </a:extLst>
           </p:cNvPr>
@@ -2799,7 +2799,7 @@
     </p:spTree>
     <p:extLst>
       <p:ext uri="{BB962C8B-B14F-4D97-AF65-F5344CB8AC3E}">
-        <p14:creationId xmlns:p14="http://schemas.microsoft.com/office/powerpoint/2010/main" val="481304058"/>
+        <p14:creationId xmlns:p14="http://schemas.microsoft.com/office/powerpoint/2010/main" val="635317507"/>
       </p:ext>
     </p:extLst>
   </p:cSld>
@@ -2823,7 +2823,7 @@
           <p:cNvPr id="13" name="Rounded-Rectangle-5-1">
             <a:extLst xmlns:a="http://schemas.openxmlformats.org/drawingml/2006/main">
               <a:ext uri="{FF2B5EF4-FFF2-40B4-BE49-F238E27FC236}">
-                <a16:creationId xmlns:a16="http://schemas.microsoft.com/office/drawing/2014/main" id="{2D30A484-FB52-4DC7-BD78-01B2AE6B9605}"/>
+                <a16:creationId xmlns:a16="http://schemas.microsoft.com/office/drawing/2014/main" id="{B6B3E6D1-8712-47F2-B3AF-AA1743EF37F7}"/>
               </a:ext>
             </a:extLst>
           </p:cNvPr>
@@ -2852,7 +2852,7 @@
           <p:cNvPr id="2" name="Rounded-Rectangle-6-2">
             <a:extLst xmlns:a="http://schemas.openxmlformats.org/drawingml/2006/main">
               <a:ext uri="{FF2B5EF4-FFF2-40B4-BE49-F238E27FC236}">
-                <a16:creationId xmlns:a16="http://schemas.microsoft.com/office/drawing/2014/main" id="{EDC13DFF-6748-4958-9705-2C26A4148AFA}"/>
+                <a16:creationId xmlns:a16="http://schemas.microsoft.com/office/drawing/2014/main" id="{37653E74-5C10-4F63-8CBF-AC519137F8A2}"/>
               </a:ext>
             </a:extLst>
           </p:cNvPr>
@@ -2881,7 +2881,7 @@
           <p:cNvPr id="3" name="Rounded-Rectangle-7-3">
             <a:extLst xmlns:a="http://schemas.openxmlformats.org/drawingml/2006/main">
               <a:ext uri="{FF2B5EF4-FFF2-40B4-BE49-F238E27FC236}">
-                <a16:creationId xmlns:a16="http://schemas.microsoft.com/office/drawing/2014/main" id="{142553C0-4AD6-47BD-A70E-79054BB9AD69}"/>
+                <a16:creationId xmlns:a16="http://schemas.microsoft.com/office/drawing/2014/main" id="{CB965529-AE49-480E-9CEE-27814B94DC45}"/>
               </a:ext>
             </a:extLst>
           </p:cNvPr>
@@ -2910,7 +2910,7 @@
           <p:cNvPr id="4" name="Slide-Number-Placeholder-1-4">
             <a:extLst xmlns:a="http://schemas.openxmlformats.org/drawingml/2006/main">
               <a:ext uri="{FF2B5EF4-FFF2-40B4-BE49-F238E27FC236}">
-                <a16:creationId xmlns:a16="http://schemas.microsoft.com/office/drawing/2014/main" id="{C48DC71B-A63D-414C-93A9-F3AFB303B3B7}"/>
+                <a16:creationId xmlns:a16="http://schemas.microsoft.com/office/drawing/2014/main" id="{EB8B984B-72A6-401D-9049-09A621A84C63}"/>
               </a:ext>
             </a:extLst>
           </p:cNvPr>
@@ -2953,7 +2953,7 @@
           <p:cNvPr id="5" name="Title-2-5">
             <a:extLst xmlns:a="http://schemas.openxmlformats.org/drawingml/2006/main">
               <a:ext uri="{FF2B5EF4-FFF2-40B4-BE49-F238E27FC236}">
-                <a16:creationId xmlns:a16="http://schemas.microsoft.com/office/drawing/2014/main" id="{A8913CE2-406C-42DD-AA23-BF048885EC15}"/>
+                <a16:creationId xmlns:a16="http://schemas.microsoft.com/office/drawing/2014/main" id="{44C2E5FE-B6AA-4271-BE3B-CD8F5BF2BB70}"/>
               </a:ext>
             </a:extLst>
           </p:cNvPr>
@@ -2998,7 +2998,7 @@
           <p:cNvPr id="6" name="Content-Placeholder-9-6">
             <a:extLst xmlns:a="http://schemas.openxmlformats.org/drawingml/2006/main">
               <a:ext uri="{FF2B5EF4-FFF2-40B4-BE49-F238E27FC236}">
-                <a16:creationId xmlns:a16="http://schemas.microsoft.com/office/drawing/2014/main" id="{6BFB07F0-AEB4-4C3A-89BD-066189E0BE24}"/>
+                <a16:creationId xmlns:a16="http://schemas.microsoft.com/office/drawing/2014/main" id="{E6B87230-8440-4CB7-81B3-0B85D54E3AD5}"/>
               </a:ext>
             </a:extLst>
           </p:cNvPr>
@@ -3043,7 +3043,7 @@
           <p:cNvPr id="7" name="Content-Placeholder-10-7">
             <a:extLst xmlns:a="http://schemas.openxmlformats.org/drawingml/2006/main">
               <a:ext uri="{FF2B5EF4-FFF2-40B4-BE49-F238E27FC236}">
-                <a16:creationId xmlns:a16="http://schemas.microsoft.com/office/drawing/2014/main" id="{03D0BAAC-D69D-45F9-9DB4-51F0BBCF8613}"/>
+                <a16:creationId xmlns:a16="http://schemas.microsoft.com/office/drawing/2014/main" id="{FA078E2F-4C12-4E61-926F-9F3B0CB33689}"/>
               </a:ext>
             </a:extLst>
           </p:cNvPr>
@@ -3088,7 +3088,7 @@
           <p:cNvPr id="8" name="Content-Placeholder-11-8">
             <a:extLst xmlns:a="http://schemas.openxmlformats.org/drawingml/2006/main">
               <a:ext uri="{FF2B5EF4-FFF2-40B4-BE49-F238E27FC236}">
-                <a16:creationId xmlns:a16="http://schemas.microsoft.com/office/drawing/2014/main" id="{0AB4135A-1202-4FF0-8A67-0C44F5ADF647}"/>
+                <a16:creationId xmlns:a16="http://schemas.microsoft.com/office/drawing/2014/main" id="{141F32FC-CB48-47ED-AF46-DACADAA6E2CA}"/>
               </a:ext>
             </a:extLst>
           </p:cNvPr>
@@ -3133,7 +3133,7 @@
           <p:cNvPr id="9" name="Content-Placeholder-9-9">
             <a:extLst xmlns:a="http://schemas.openxmlformats.org/drawingml/2006/main">
               <a:ext uri="{FF2B5EF4-FFF2-40B4-BE49-F238E27FC236}">
-                <a16:creationId xmlns:a16="http://schemas.microsoft.com/office/drawing/2014/main" id="{B581EB2B-7BF7-4831-B70D-57769D126CC2}"/>
+                <a16:creationId xmlns:a16="http://schemas.microsoft.com/office/drawing/2014/main" id="{D81330D6-505B-4C28-8161-F5F3595D97E1}"/>
               </a:ext>
             </a:extLst>
           </p:cNvPr>
@@ -3178,7 +3178,7 @@
           <p:cNvPr id="10" name="Content-Placeholder-9-10">
             <a:extLst xmlns:a="http://schemas.openxmlformats.org/drawingml/2006/main">
               <a:ext uri="{FF2B5EF4-FFF2-40B4-BE49-F238E27FC236}">
-                <a16:creationId xmlns:a16="http://schemas.microsoft.com/office/drawing/2014/main" id="{4A6DC765-FB2A-4E9C-9ECB-40C5E3213ABE}"/>
+                <a16:creationId xmlns:a16="http://schemas.microsoft.com/office/drawing/2014/main" id="{0C6DB908-E8DA-4C93-B33E-ABD934CA1253}"/>
               </a:ext>
             </a:extLst>
           </p:cNvPr>
@@ -3223,7 +3223,7 @@
           <p:cNvPr id="11" name="Content-Placeholder-9-11">
             <a:extLst xmlns:a="http://schemas.openxmlformats.org/drawingml/2006/main">
               <a:ext uri="{FF2B5EF4-FFF2-40B4-BE49-F238E27FC236}">
-                <a16:creationId xmlns:a16="http://schemas.microsoft.com/office/drawing/2014/main" id="{1C472481-BD4D-4ABF-B555-6D123C2AE2AA}"/>
+                <a16:creationId xmlns:a16="http://schemas.microsoft.com/office/drawing/2014/main" id="{B02580DB-1F1B-43F6-8835-5CDC60257728}"/>
               </a:ext>
             </a:extLst>
           </p:cNvPr>
@@ -3268,7 +3268,7 @@
           <p:cNvPr id="12" name="Content-Placeholder-15-12">
             <a:extLst xmlns:a="http://schemas.openxmlformats.org/drawingml/2006/main">
               <a:ext uri="{FF2B5EF4-FFF2-40B4-BE49-F238E27FC236}">
-                <a16:creationId xmlns:a16="http://schemas.microsoft.com/office/drawing/2014/main" id="{282BF337-992C-420D-8406-033FF41D489E}"/>
+                <a16:creationId xmlns:a16="http://schemas.microsoft.com/office/drawing/2014/main" id="{8EB27344-9EB8-4B9B-8346-F05EA3CEE74E}"/>
               </a:ext>
             </a:extLst>
           </p:cNvPr>
@@ -3326,7 +3326,7 @@
     </p:spTree>
     <p:extLst>
       <p:ext uri="{BB962C8B-B14F-4D97-AF65-F5344CB8AC3E}">
-        <p14:creationId xmlns:p14="http://schemas.microsoft.com/office/powerpoint/2010/main" val="1639644971"/>
+        <p14:creationId xmlns:p14="http://schemas.microsoft.com/office/powerpoint/2010/main" val="1238800619"/>
       </p:ext>
     </p:extLst>
   </p:cSld>
@@ -3350,7 +3350,7 @@
           <p:cNvPr id="4" name="Title-3-1">
             <a:extLst xmlns:a="http://schemas.openxmlformats.org/drawingml/2006/main">
               <a:ext uri="{FF2B5EF4-FFF2-40B4-BE49-F238E27FC236}">
-                <a16:creationId xmlns:a16="http://schemas.microsoft.com/office/drawing/2014/main" id="{4EEAF2B0-7386-45E9-AF68-6B538CA944DA}"/>
+                <a16:creationId xmlns:a16="http://schemas.microsoft.com/office/drawing/2014/main" id="{F7D86888-40D5-46BB-B3BF-CDC3AA8A98A3}"/>
               </a:ext>
             </a:extLst>
           </p:cNvPr>
@@ -3395,7 +3395,7 @@
           <p:cNvPr id="2" name="Subtitle-4-2">
             <a:extLst xmlns:a="http://schemas.openxmlformats.org/drawingml/2006/main">
               <a:ext uri="{FF2B5EF4-FFF2-40B4-BE49-F238E27FC236}">
-                <a16:creationId xmlns:a16="http://schemas.microsoft.com/office/drawing/2014/main" id="{EB21DF72-3CEC-4B2D-90E3-0970742BC4F5}"/>
+                <a16:creationId xmlns:a16="http://schemas.microsoft.com/office/drawing/2014/main" id="{91AA51D9-967C-4136-A378-176B3C2C756A}"/>
               </a:ext>
             </a:extLst>
           </p:cNvPr>
@@ -3445,7 +3445,7 @@
               </a:defRPr>
             </a:pPr>
             <a:r>
-              <a:t>Add Google + Anthropic</a:t>
+              <a:t>Connect shared live evals</a:t>
             </a:r>
           </a:p>
           <a:p xmlns:a="http://schemas.openxmlformats.org/drawingml/2006/main">
@@ -3470,7 +3470,7 @@
           <p:cNvPr id="3" name="Subtitle-4-3">
             <a:extLst xmlns:a="http://schemas.openxmlformats.org/drawingml/2006/main">
               <a:ext uri="{FF2B5EF4-FFF2-40B4-BE49-F238E27FC236}">
-                <a16:creationId xmlns:a16="http://schemas.microsoft.com/office/drawing/2014/main" id="{AD8E6EBF-62AC-463D-8F18-4EB67C3267BA}"/>
+                <a16:creationId xmlns:a16="http://schemas.microsoft.com/office/drawing/2014/main" id="{25F53C8E-ECA4-45A7-97AF-21974A5787B3}"/>
               </a:ext>
             </a:extLst>
           </p:cNvPr>
@@ -3513,7 +3513,7 @@
     </p:spTree>
     <p:extLst>
       <p:ext uri="{BB962C8B-B14F-4D97-AF65-F5344CB8AC3E}">
-        <p14:creationId xmlns:p14="http://schemas.microsoft.com/office/powerpoint/2010/main" val="1186350966"/>
+        <p14:creationId xmlns:p14="http://schemas.microsoft.com/office/powerpoint/2010/main" val="418395625"/>
       </p:ext>
     </p:extLst>
   </p:cSld>

</xml_diff>